<commit_message>
Add Power BI Project (.pbip) with TMDL model and PBIR report for project 3
- src/build_pbip.py: deterministic generator that builds powerbi/pbip/ from
  the star-schema CSVs, measures.dax, the theme and the dashboard spec
- Semantic model (TMDL): 11 star-schema tables + data_quality_scorecard +
  _Measures, typed M partitions driven by a DataFolder parameter, 14
  relationships (3 inactive), 122 measures in display folders, date table
  marked, sort-by columns, hidden keys
- Report (PBIR): 8 pages / 130 visuals per dashboard_spec.md, synced slicer
  rail, navy & teal theme, drill-through patient list, pre-filtered outreach
  table; every JSON file validated against Microsoft's published schemas
- measures.dax: add Condition Records helper measure
- README / spec / deck: how to open the .pbip and set DataFolder

Co-Authored-By: Claude Fable 5.1 <noreply@anthropic.com>
Claude-Session: https://claude.ai/code/session_01Q7XU8zwB8rNndE7EG4kVZb
</commit_message>
<xml_diff>
--- a/03-population-health-powerbi/docs/Population_Health_Dashboard.pptx
+++ b/03-population-health-powerbi/docs/Population_Health_Dashboard.pptx
@@ -6054,7 +6054,7 @@
                 <a:ea typeface="Calibri" pitchFamily="34" charset="-122"/>
                 <a:cs typeface="Calibri" pitchFamily="34" charset="-120"/>
               </a:rPr>
-              <a:t>Build the .pbix: import the 11 CSVs, paste measures.dax, apply the theme</a:t>
+              <a:t>Open powerbi/pbip in Power BI Desktop and point DataFolder at the star schema</a:t>
             </a:r>
             <a:endParaRPr lang="en-US" sz="1050" dirty="0"/>
           </a:p>
@@ -6177,7 +6177,7 @@
                 <a:ea typeface="Calibri" pitchFamily="34" charset="-122"/>
                 <a:cs typeface="Calibri" pitchFamily="34" charset="-120"/>
               </a:rPr>
-              <a:t>Deliverables: src/generate_synthetic_data.py · notebooks/01_clean_and_build_star_schema.ipynb · data/star_schema/ · powerbi/measures.dax · powerbi/dashboard_spec.md · powerbi/theme_navy_teal.json · README.md</a:t>
+              <a:t>Deliverables: src/generate_synthetic_data.py · notebooks/01_clean_and_build_star_schema.ipynb · data/star_schema/ · powerbi/pbip (TMDL model + PBIR report) · powerbi/measures.dax · powerbi/dashboard_spec.md · README.md</a:t>
             </a:r>
             <a:endParaRPr lang="en-US" sz="1050" dirty="0"/>
           </a:p>

</xml_diff>